<commit_message>
Corrected typos in sldies
</commit_message>
<xml_diff>
--- a/LectureSlides/06b_IntroductionToBootstrap.pptx
+++ b/LectureSlides/06b_IntroductionToBootstrap.pptx
@@ -239,7 +239,7 @@
           <a:p>
             <a:fld id="{04109FAC-1BEC-4087-B676-5D9DDF25C61E}" type="datetimeFigureOut">
               <a:rPr lang="en-US" smtClean="0"/>
-              <a:t>9/18/2025</a:t>
+              <a:t>9/16/2026</a:t>
             </a:fld>
             <a:endParaRPr lang="en-US"/>
           </a:p>
@@ -772,7 +772,7 @@
           <a:p>
             <a:fld id="{241EB5C9-1307-BA42-ABA2-0BC069CD8E7F}" type="datetimeFigureOut">
               <a:rPr lang="en-US" smtClean="0"/>
-              <a:t>9/18/2025</a:t>
+              <a:t>9/16/2026</a:t>
             </a:fld>
             <a:endParaRPr lang="en-US"/>
           </a:p>
@@ -940,7 +940,7 @@
           <a:p>
             <a:fld id="{241EB5C9-1307-BA42-ABA2-0BC069CD8E7F}" type="datetimeFigureOut">
               <a:rPr lang="en-US" smtClean="0"/>
-              <a:t>9/18/2025</a:t>
+              <a:t>9/16/2026</a:t>
             </a:fld>
             <a:endParaRPr lang="en-US"/>
           </a:p>
@@ -1118,7 +1118,7 @@
           <a:p>
             <a:fld id="{241EB5C9-1307-BA42-ABA2-0BC069CD8E7F}" type="datetimeFigureOut">
               <a:rPr lang="en-US" smtClean="0"/>
-              <a:t>9/18/2025</a:t>
+              <a:t>9/16/2026</a:t>
             </a:fld>
             <a:endParaRPr lang="en-US"/>
           </a:p>
@@ -1286,7 +1286,7 @@
           <a:p>
             <a:fld id="{241EB5C9-1307-BA42-ABA2-0BC069CD8E7F}" type="datetimeFigureOut">
               <a:rPr lang="en-US" smtClean="0"/>
-              <a:t>9/18/2025</a:t>
+              <a:t>9/16/2026</a:t>
             </a:fld>
             <a:endParaRPr lang="en-US"/>
           </a:p>
@@ -1531,7 +1531,7 @@
           <a:p>
             <a:fld id="{241EB5C9-1307-BA42-ABA2-0BC069CD8E7F}" type="datetimeFigureOut">
               <a:rPr lang="en-US" smtClean="0"/>
-              <a:t>9/18/2025</a:t>
+              <a:t>9/16/2026</a:t>
             </a:fld>
             <a:endParaRPr lang="en-US"/>
           </a:p>
@@ -1816,7 +1816,7 @@
           <a:p>
             <a:fld id="{241EB5C9-1307-BA42-ABA2-0BC069CD8E7F}" type="datetimeFigureOut">
               <a:rPr lang="en-US" smtClean="0"/>
-              <a:t>9/18/2025</a:t>
+              <a:t>9/16/2026</a:t>
             </a:fld>
             <a:endParaRPr lang="en-US"/>
           </a:p>
@@ -2235,7 +2235,7 @@
           <a:p>
             <a:fld id="{241EB5C9-1307-BA42-ABA2-0BC069CD8E7F}" type="datetimeFigureOut">
               <a:rPr lang="en-US" smtClean="0"/>
-              <a:t>9/18/2025</a:t>
+              <a:t>9/16/2026</a:t>
             </a:fld>
             <a:endParaRPr lang="en-US"/>
           </a:p>
@@ -2352,7 +2352,7 @@
           <a:p>
             <a:fld id="{241EB5C9-1307-BA42-ABA2-0BC069CD8E7F}" type="datetimeFigureOut">
               <a:rPr lang="en-US" smtClean="0"/>
-              <a:t>9/18/2025</a:t>
+              <a:t>9/16/2026</a:t>
             </a:fld>
             <a:endParaRPr lang="en-US"/>
           </a:p>
@@ -2447,7 +2447,7 @@
           <a:p>
             <a:fld id="{241EB5C9-1307-BA42-ABA2-0BC069CD8E7F}" type="datetimeFigureOut">
               <a:rPr lang="en-US" smtClean="0"/>
-              <a:t>9/18/2025</a:t>
+              <a:t>9/16/2026</a:t>
             </a:fld>
             <a:endParaRPr lang="en-US"/>
           </a:p>
@@ -2722,7 +2722,7 @@
           <a:p>
             <a:fld id="{241EB5C9-1307-BA42-ABA2-0BC069CD8E7F}" type="datetimeFigureOut">
               <a:rPr lang="en-US" smtClean="0"/>
-              <a:t>9/18/2025</a:t>
+              <a:t>9/16/2026</a:t>
             </a:fld>
             <a:endParaRPr lang="en-US"/>
           </a:p>
@@ -2974,7 +2974,7 @@
           <a:p>
             <a:fld id="{241EB5C9-1307-BA42-ABA2-0BC069CD8E7F}" type="datetimeFigureOut">
               <a:rPr lang="en-US" smtClean="0"/>
-              <a:t>9/18/2025</a:t>
+              <a:t>9/16/2026</a:t>
             </a:fld>
             <a:endParaRPr lang="en-US"/>
           </a:p>
@@ -3185,7 +3185,7 @@
           <a:p>
             <a:fld id="{241EB5C9-1307-BA42-ABA2-0BC069CD8E7F}" type="datetimeFigureOut">
               <a:rPr lang="en-US" smtClean="0"/>
-              <a:t>9/18/2025</a:t>
+              <a:t>9/16/2026</a:t>
             </a:fld>
             <a:endParaRPr lang="en-US"/>
           </a:p>
@@ -3866,8 +3866,8 @@
           </a:p>
         </p:txBody>
       </p:sp>
-      <mc:AlternateContent xmlns:mc="http://schemas.openxmlformats.org/markup-compatibility/2006">
-        <mc:Choice xmlns:a14="http://schemas.microsoft.com/office/drawing/2010/main" Requires="a14">
+      <mc:AlternateContent xmlns:mc="http://schemas.openxmlformats.org/markup-compatibility/2006" xmlns:a14="http://schemas.microsoft.com/office/drawing/2010/main">
+        <mc:Choice Requires="a14">
           <p:sp>
             <p:nvSpPr>
               <p:cNvPr id="6" name="Content Placeholder 2">
@@ -4057,7 +4057,7 @@
                       <m:accPr>
                         <m:chr m:val="̂"/>
                         <m:ctrlPr>
-                          <a:rPr lang="ar-AE" i="1">
+                          <a:rPr lang="ar-AE">
                             <a:latin typeface="Cambria Math" panose="02040503050406030204" pitchFamily="18" charset="0"/>
                           </a:rPr>
                         </m:ctrlPr>
@@ -4101,7 +4101,7 @@
                     <m:sSup>
                       <m:sSupPr>
                         <m:ctrlPr>
-                          <a:rPr lang="en-US" i="1" smtClean="0">
+                          <a:rPr lang="ar-AE" i="1">
                             <a:latin typeface="Cambria Math" panose="02040503050406030204" pitchFamily="18" charset="0"/>
                           </a:rPr>
                         </m:ctrlPr>
@@ -4111,7 +4111,7 @@
                           <m:accPr>
                             <m:chr m:val="̂"/>
                             <m:ctrlPr>
-                              <a:rPr lang="ar-AE" i="1">
+                              <a:rPr lang="ar-AE">
                                 <a:latin typeface="Cambria Math" panose="02040503050406030204" pitchFamily="18" charset="0"/>
                               </a:rPr>
                             </m:ctrlPr>
@@ -4159,7 +4159,7 @@
                     <m:d>
                       <m:dPr>
                         <m:ctrlPr>
-                          <a:rPr lang="ar-AE" i="1">
+                          <a:rPr lang="en-US" i="1">
                             <a:latin typeface="Cambria Math" panose="02040503050406030204" pitchFamily="18" charset="0"/>
                           </a:rPr>
                         </m:ctrlPr>
@@ -4168,7 +4168,7 @@
                         <m:sSup>
                           <m:sSupPr>
                             <m:ctrlPr>
-                              <a:rPr lang="en-US" i="1">
+                              <a:rPr lang="ar-AE" i="1">
                                 <a:latin typeface="Cambria Math" panose="02040503050406030204" pitchFamily="18" charset="0"/>
                               </a:rPr>
                             </m:ctrlPr>
@@ -4178,7 +4178,7 @@
                               <m:accPr>
                                 <m:chr m:val="̂"/>
                                 <m:ctrlPr>
-                                  <a:rPr lang="ar-AE" i="1">
+                                  <a:rPr lang="ar-AE">
                                     <a:latin typeface="Cambria Math" panose="02040503050406030204" pitchFamily="18" charset="0"/>
                                   </a:rPr>
                                 </m:ctrlPr>
@@ -4232,7 +4232,7 @@
             </p:txBody>
           </p:sp>
         </mc:Choice>
-        <mc:Fallback>
+        <mc:Fallback xmlns="">
           <p:sp>
             <p:nvSpPr>
               <p:cNvPr id="6" name="Content Placeholder 2">
@@ -4293,8 +4293,8 @@
         </p:nvCxnSpPr>
         <p:spPr>
           <a:xfrm>
-            <a:off x="2915160" y="2173006"/>
-            <a:ext cx="1831407" cy="170676"/>
+            <a:off x="3267456" y="2173006"/>
+            <a:ext cx="1479111" cy="170676"/>
           </a:xfrm>
           <a:prstGeom prst="straightConnector1">
             <a:avLst/>
@@ -4337,8 +4337,8 @@
         </p:nvCxnSpPr>
         <p:spPr>
           <a:xfrm>
-            <a:off x="3545378" y="2943188"/>
-            <a:ext cx="552797" cy="86555"/>
+            <a:off x="3812032" y="2877312"/>
+            <a:ext cx="286143" cy="113792"/>
           </a:xfrm>
           <a:prstGeom prst="straightConnector1">
             <a:avLst/>
@@ -8341,6 +8341,7 @@
                     <m:groupChr>
                       <m:groupChrPr>
                         <m:chr m:val="→"/>
+                        <m:pos m:val="bot"/>
                         <m:vertJc m:val="bot"/>
                         <m:ctrlPr>
                           <a:rPr lang="en-US" sz="1350" b="1" i="1">
@@ -8492,6 +8493,7 @@
                     <m:groupChr>
                       <m:groupChrPr>
                         <m:chr m:val="→"/>
+                        <m:pos m:val="bot"/>
                         <m:vertJc m:val="bot"/>
                         <m:ctrlPr>
                           <a:rPr lang="en-US" sz="1350" b="1" i="1">
@@ -8643,6 +8645,7 @@
                     <m:groupChr>
                       <m:groupChrPr>
                         <m:chr m:val="→"/>
+                        <m:pos m:val="bot"/>
                         <m:vertJc m:val="bot"/>
                         <m:ctrlPr>
                           <a:rPr lang="en-US" sz="1350" b="1" i="1">
@@ -8794,6 +8797,7 @@
                     <m:groupChr>
                       <m:groupChrPr>
                         <m:chr m:val="→"/>
+                        <m:pos m:val="bot"/>
                         <m:vertJc m:val="bot"/>
                         <m:ctrlPr>
                           <a:rPr lang="en-US" sz="1350" b="1" i="1">
@@ -8943,10 +8947,7 @@
                 <a:pPr/>
                 <a14:m>
                   <m:oMathPara xmlns:m="http://schemas.openxmlformats.org/officeDocument/2006/math">
-                    <m:oMathParaPr>
-                      <m:jc m:val="centerGroup"/>
-                    </m:oMathParaPr>
-                    <m:oMath xmlns:m="http://schemas.openxmlformats.org/officeDocument/2006/math">
+                    <m:oMath>
                       <m:sSub>
                         <m:sSubPr>
                           <m:ctrlPr>
@@ -12241,8 +12242,8 @@
               <a:buNone/>
             </a:pPr>
             <a:r>
-              <a:rPr lang="en-US" dirty="0" err="1"/>
-              <a:t>Propoerties</a:t>
+              <a:rPr lang="en-US" dirty="0"/>
+              <a:t>Properties</a:t>
             </a:r>
             <a:r>
               <a:rPr dirty="0"/>
@@ -14351,7 +14352,7 @@
                     <m:sSub>
                       <m:sSubPr>
                         <m:ctrlPr>
-                          <a:rPr lang="ar-AE" i="1">
+                          <a:rPr lang="ar-AE">
                             <a:latin typeface="Cambria Math" panose="02040503050406030204" pitchFamily="18" charset="0"/>
                           </a:rPr>
                         </m:ctrlPr>
@@ -14397,7 +14398,7 @@
                     <m:sSub>
                       <m:sSubPr>
                         <m:ctrlPr>
-                          <a:rPr lang="ar-AE" i="1" smtClean="0">
+                          <a:rPr lang="ar-AE" b="0" i="1" smtClean="0">
                             <a:latin typeface="Cambria Math" panose="02040503050406030204" pitchFamily="18" charset="0"/>
                           </a:rPr>
                         </m:ctrlPr>
@@ -14447,13 +14448,7 @@
                       <a:rPr lang="ar-AE">
                         <a:latin typeface="Cambria Math" panose="02040503050406030204" pitchFamily="18" charset="0"/>
                       </a:rPr>
-                      <m:t>/</m:t>
-                    </m:r>
-                    <m:r>
-                      <a:rPr lang="ar-AE">
-                        <a:latin typeface="Cambria Math" panose="02040503050406030204" pitchFamily="18" charset="0"/>
-                      </a:rPr>
-                      <m:t>2</m:t>
+                      <m:t>/2</m:t>
                     </m:r>
                   </m:oMath>
                 </a14:m>
@@ -14521,7 +14516,7 @@
                     <m:d>
                       <m:dPr>
                         <m:ctrlPr>
-                          <a:rPr lang="ar-AE" i="1">
+                          <a:rPr lang="ar-AE">
                             <a:latin typeface="Cambria Math" panose="02040503050406030204" pitchFamily="18" charset="0"/>
                           </a:rPr>
                         </m:ctrlPr>
@@ -14531,13 +14526,7 @@
                           <a:rPr lang="ar-AE">
                             <a:latin typeface="Cambria Math" panose="02040503050406030204" pitchFamily="18" charset="0"/>
                           </a:rPr>
-                          <m:t>1</m:t>
-                        </m:r>
-                        <m:r>
-                          <a:rPr lang="ar-AE">
-                            <a:latin typeface="Cambria Math" panose="02040503050406030204" pitchFamily="18" charset="0"/>
-                          </a:rPr>
-                          <m:t>−</m:t>
+                          <m:t>1−</m:t>
                         </m:r>
                         <m:r>
                           <a:rPr lang="ar-AE">
@@ -14549,13 +14538,7 @@
                           <a:rPr lang="ar-AE">
                             <a:latin typeface="Cambria Math" panose="02040503050406030204" pitchFamily="18" charset="0"/>
                           </a:rPr>
-                          <m:t>/</m:t>
-                        </m:r>
-                        <m:r>
-                          <a:rPr lang="ar-AE">
-                            <a:latin typeface="Cambria Math" panose="02040503050406030204" pitchFamily="18" charset="0"/>
-                          </a:rPr>
-                          <m:t>2</m:t>
+                          <m:t>/2</m:t>
                         </m:r>
                       </m:e>
                     </m:d>
@@ -21766,7 +21749,7 @@
                       <m:accPr>
                         <m:chr m:val="‾"/>
                         <m:ctrlPr>
-                          <a:rPr i="1">
+                          <a:rPr>
                             <a:latin typeface="Cambria Math" panose="02040503050406030204" pitchFamily="18" charset="0"/>
                           </a:rPr>
                         </m:ctrlPr>
@@ -23293,7 +23276,7 @@
                       <m:accPr>
                         <m:chr m:val="‾"/>
                         <m:ctrlPr>
-                          <a:rPr i="1">
+                          <a:rPr>
                             <a:latin typeface="Cambria Math" panose="02040503050406030204" pitchFamily="18" charset="0"/>
                           </a:rPr>
                         </m:ctrlPr>

</xml_diff>